<commit_message>
Add official team details (code Kanyarasi - V. Chandu - VIT AP) and AI video explanation guide
</commit_message>
<xml_diff>
--- a/docs/HeartFailureTwin_Presentation.pptx
+++ b/docs/HeartFailureTwin_Presentation.pptx
@@ -3397,7 +3397,7 @@
                   <a:srgbClr val="F8FAFC"/>
                 </a:solidFill>
               </a:rPr>
-              <a:t>[Enter Team Name Here]</a:t>
+              <a:t>code Kanyarasi</a:t>
             </a:r>
           </a:p>
           <a:p>
@@ -3409,7 +3409,7 @@
               </a:defRPr>
             </a:pPr>
             <a:r>
-              <a:t>Team Members: </a:t>
+              <a:t>Team Member: </a:t>
             </a:r>
             <a:r>
               <a:rPr b="0" sz="1300">
@@ -3417,7 +3417,7 @@
                   <a:srgbClr val="F8FAFC"/>
                 </a:solidFill>
               </a:rPr>
-              <a:t>[Member 1 (Lead), Member 2, Member 3]</a:t>
+              <a:t>V. Chandu (Sole Developer &amp; Researcher)</a:t>
             </a:r>
           </a:p>
           <a:p>
@@ -3429,7 +3429,7 @@
               </a:defRPr>
             </a:pPr>
             <a:r>
-              <a:t>College / Incubator: </a:t>
+              <a:t>Email: </a:t>
             </a:r>
             <a:r>
               <a:rPr b="0" sz="1300">
@@ -3437,7 +3437,27 @@
                   <a:srgbClr val="F8FAFC"/>
                 </a:solidFill>
               </a:rPr>
-              <a:t>[Institution / University / Incubator Name]</a:t>
+              <a:t>valligatlachandu@gmail.com</a:t>
+            </a:r>
+          </a:p>
+          <a:p>
+            <a:pPr>
+              <a:defRPr b="1" sz="1300">
+                <a:solidFill>
+                  <a:srgbClr val="38BDF8"/>
+                </a:solidFill>
+              </a:defRPr>
+            </a:pPr>
+            <a:r>
+              <a:t>College / Institute: </a:t>
+            </a:r>
+            <a:r>
+              <a:rPr b="0" sz="1300">
+                <a:solidFill>
+                  <a:srgbClr val="F8FAFC"/>
+                </a:solidFill>
+              </a:rPr>
+              <a:t>Vellore Institute of Technology AP</a:t>
             </a:r>
           </a:p>
           <a:p>

</xml_diff>

<commit_message>
Update team details with 3 members: V Chandu (Leader), Vonteddu Sri Sai Himanish Reddy, and Aditya Vihar Repaka
</commit_message>
<xml_diff>
--- a/docs/HeartFailureTwin_Presentation.pptx
+++ b/docs/HeartFailureTwin_Presentation.pptx
@@ -3362,7 +3362,7 @@
           </a:p>
           <a:p>
             <a:pPr>
-              <a:defRPr b="1" sz="1300">
+              <a:defRPr b="1" sz="1100">
                 <a:solidFill>
                   <a:srgbClr val="38BDF8"/>
                 </a:solidFill>
@@ -3372,7 +3372,7 @@
               <a:t>Track: </a:t>
             </a:r>
             <a:r>
-              <a:rPr b="0" sz="1300">
+              <a:rPr b="0" sz="1100">
                 <a:solidFill>
                   <a:srgbClr val="F8FAFC"/>
                 </a:solidFill>
@@ -3382,7 +3382,7 @@
           </a:p>
           <a:p>
             <a:pPr>
-              <a:defRPr b="1" sz="1300">
+              <a:defRPr b="1" sz="1100">
                 <a:solidFill>
                   <a:srgbClr val="38BDF8"/>
                 </a:solidFill>
@@ -3392,57 +3392,77 @@
               <a:t>Team Name: </a:t>
             </a:r>
             <a:r>
-              <a:rPr b="0" sz="1300">
+              <a:rPr b="0" sz="1100">
                 <a:solidFill>
                   <a:srgbClr val="F8FAFC"/>
                 </a:solidFill>
               </a:rPr>
-              <a:t>code Kanyarasi</a:t>
-            </a:r>
-          </a:p>
-          <a:p>
-            <a:pPr>
-              <a:defRPr b="1" sz="1300">
+              <a:t>code Kanyarasi (Unstop: valligatlachandu)</a:t>
+            </a:r>
+          </a:p>
+          <a:p>
+            <a:pPr>
+              <a:defRPr b="1" sz="1100">
                 <a:solidFill>
                   <a:srgbClr val="38BDF8"/>
                 </a:solidFill>
               </a:defRPr>
             </a:pPr>
             <a:r>
+              <a:t>Team Leader: </a:t>
+            </a:r>
+            <a:r>
+              <a:rPr b="0" sz="1100">
+                <a:solidFill>
+                  <a:srgbClr val="F8FAFC"/>
+                </a:solidFill>
+              </a:rPr>
+              <a:t>V Chandu (+91 9390340329 | valligatlachandu@gmail.com)</a:t>
+            </a:r>
+          </a:p>
+          <a:p>
+            <a:pPr>
+              <a:defRPr b="1" sz="1100">
+                <a:solidFill>
+                  <a:srgbClr val="38BDF8"/>
+                </a:solidFill>
+              </a:defRPr>
+            </a:pPr>
+            <a:r>
               <a:t>Team Member: </a:t>
             </a:r>
             <a:r>
-              <a:rPr b="0" sz="1300">
+              <a:rPr b="0" sz="1100">
                 <a:solidFill>
                   <a:srgbClr val="F8FAFC"/>
                 </a:solidFill>
               </a:rPr>
-              <a:t>V. Chandu (Sole Developer &amp; Researcher)</a:t>
-            </a:r>
-          </a:p>
-          <a:p>
-            <a:pPr>
-              <a:defRPr b="1" sz="1300">
+              <a:t>Vonteddu Sri Sai Himanish Reddy (+91 9392504793)</a:t>
+            </a:r>
+          </a:p>
+          <a:p>
+            <a:pPr>
+              <a:defRPr b="1" sz="1100">
                 <a:solidFill>
                   <a:srgbClr val="38BDF8"/>
                 </a:solidFill>
               </a:defRPr>
             </a:pPr>
             <a:r>
-              <a:t>Email: </a:t>
-            </a:r>
-            <a:r>
-              <a:rPr b="0" sz="1300">
+              <a:t>Team Member: </a:t>
+            </a:r>
+            <a:r>
+              <a:rPr b="0" sz="1100">
                 <a:solidFill>
                   <a:srgbClr val="F8FAFC"/>
                 </a:solidFill>
               </a:rPr>
-              <a:t>valligatlachandu@gmail.com</a:t>
-            </a:r>
-          </a:p>
-          <a:p>
-            <a:pPr>
-              <a:defRPr b="1" sz="1300">
+              <a:t>Aditya Vihar Repaka (+91 8555857555)</a:t>
+            </a:r>
+          </a:p>
+          <a:p>
+            <a:pPr>
+              <a:defRPr b="1" sz="1100">
                 <a:solidFill>
                   <a:srgbClr val="38BDF8"/>
                 </a:solidFill>
@@ -3452,17 +3472,17 @@
               <a:t>College / Institute: </a:t>
             </a:r>
             <a:r>
-              <a:rPr b="0" sz="1300">
+              <a:rPr b="0" sz="1100">
                 <a:solidFill>
                   <a:srgbClr val="F8FAFC"/>
                 </a:solidFill>
               </a:rPr>
-              <a:t>Vellore Institute of Technology AP</a:t>
-            </a:r>
-          </a:p>
-          <a:p>
-            <a:pPr>
-              <a:defRPr b="1" sz="1300">
+              <a:t>Vellore Institute of Technology AP (VIT-AP)</a:t>
+            </a:r>
+          </a:p>
+          <a:p>
+            <a:pPr>
+              <a:defRPr b="1" sz="1100">
                 <a:solidFill>
                   <a:srgbClr val="38BDF8"/>
                 </a:solidFill>
@@ -3472,7 +3492,7 @@
               <a:t>Submission Scope: </a:t>
             </a:r>
             <a:r>
-              <a:rPr b="0" sz="1300">
+              <a:rPr b="0" sz="1100">
                 <a:solidFill>
                   <a:srgbClr val="F8FAFC"/>
                 </a:solidFill>
@@ -3482,7 +3502,7 @@
           </a:p>
           <a:p>
             <a:pPr>
-              <a:defRPr b="1" sz="1300">
+              <a:defRPr b="1" sz="1100">
                 <a:solidFill>
                   <a:srgbClr val="38BDF8"/>
                 </a:solidFill>
@@ -3492,7 +3512,7 @@
               <a:t>Medical Disclaimer: </a:t>
             </a:r>
             <a:r>
-              <a:rPr b="0" sz="1300">
+              <a:rPr b="0" sz="1100">
                 <a:solidFill>
                   <a:srgbClr val="F8FAFC"/>
                 </a:solidFill>

</xml_diff>